<commit_message>
Docs: guide utilisateur avec captures d'écran réelles intégrées
10 écrans capturés automatiquement sur une stack locale isolée (données factices,
aucune donnée client réelle) et embarqués dans le .docx et le .pptx : connexion,
accueil client, identité, vue d'ensemble admin (KPI), config, utilisateurs,
tableau des transactions, espace conseiller, recherche + fiche imprimeur.
Les écrans caméra/validation MoMo restent en emplacement à remplir.

Co-Authored-By: Claude Opus 4.8 (1M context) <noreply@anthropic.com>
</commit_message>
<xml_diff>
--- a/docs/Guide-utilisateur-Carte-Promote.pptx
+++ b/docs/Guide-utilisateur-Carte-Promote.pptx
@@ -35,7 +35,6 @@
     <p:sldId id="283" r:id="rId28"/>
     <p:sldId id="284" r:id="rId29"/>
     <p:sldId id="285" r:id="rId30"/>
-    <p:sldId id="286" r:id="rId31"/>
   </p:sldIdLst>
   <p:sldSz cx="12192000" cy="6858000" type="screen16x9"/>
   <p:notesSz cx="6858000" cy="9144000"/>
@@ -173,7 +172,7 @@
         </p:nvSpPr>
         <p:spPr>
           <a:xfrm>
-            <a:off x="800000" y="2200000"/>
+            <a:off x="800000" y="2100000"/>
             <a:ext cx="10592000" cy="1600000"/>
           </a:xfrm>
           <a:prstGeom prst="rect">
@@ -209,8 +208,8 @@
         </p:nvSpPr>
         <p:spPr>
           <a:xfrm>
-            <a:off x="800000" y="3700000"/>
-            <a:ext cx="10592000" cy="1400000"/>
+            <a:off x="800000" y="3650000"/>
+            <a:ext cx="10592000" cy="1600000"/>
           </a:xfrm>
           <a:prstGeom prst="rect">
             <a:avLst/>
@@ -271,7 +270,7 @@
                   <a:srgbClr val="555555"/>
                 </a:solidFill>
               </a:rPr>
-              <a:t>• Les cadres « 📷 Capture » sont à remplir avec vos propres copies d'écran.</a:t>
+              <a:t>• Captures réelles ci-après ; les écrans caméra/validation MoMo restent en emplacement à remplir.</a:t>
             </a:r>
           </a:p>
         </p:txBody>
@@ -334,7 +333,7 @@
         </p:nvSpPr>
         <p:spPr>
           <a:xfrm>
-            <a:off x="500000" y="380000"/>
+            <a:off x="500000" y="360000"/>
             <a:ext cx="11192000" cy="760000"/>
           </a:xfrm>
           <a:prstGeom prst="rect">
@@ -371,7 +370,7 @@
         <p:spPr>
           <a:xfrm>
             <a:off x="500000" y="1300000"/>
-            <a:ext cx="5500000" cy="5158000"/>
+            <a:ext cx="5300000" cy="5158000"/>
           </a:xfrm>
           <a:prstGeom prst="rect">
             <a:avLst/>
@@ -432,8 +431,8 @@
         </p:nvSpPr>
         <p:spPr>
           <a:xfrm>
-            <a:off x="6250000" y="1300000"/>
-            <a:ext cx="5400000" cy="4700000"/>
+            <a:off x="6050000" y="1250000"/>
+            <a:ext cx="5650000" cy="5050000"/>
           </a:xfrm>
           <a:prstGeom prst="rect">
             <a:avLst/>
@@ -552,7 +551,7 @@
         </p:nvSpPr>
         <p:spPr>
           <a:xfrm>
-            <a:off x="500000" y="380000"/>
+            <a:off x="500000" y="360000"/>
             <a:ext cx="11192000" cy="760000"/>
           </a:xfrm>
           <a:prstGeom prst="rect">
@@ -589,7 +588,7 @@
         <p:spPr>
           <a:xfrm>
             <a:off x="500000" y="1300000"/>
-            <a:ext cx="5500000" cy="5158000"/>
+            <a:ext cx="5300000" cy="5158000"/>
           </a:xfrm>
           <a:prstGeom prst="rect">
             <a:avLst/>
@@ -650,8 +649,8 @@
         </p:nvSpPr>
         <p:spPr>
           <a:xfrm>
-            <a:off x="6250000" y="1300000"/>
-            <a:ext cx="5400000" cy="4700000"/>
+            <a:off x="6050000" y="1250000"/>
+            <a:ext cx="5650000" cy="5050000"/>
           </a:xfrm>
           <a:prstGeom prst="rect">
             <a:avLst/>
@@ -770,7 +769,7 @@
         </p:nvSpPr>
         <p:spPr>
           <a:xfrm>
-            <a:off x="500000" y="380000"/>
+            <a:off x="500000" y="360000"/>
             <a:ext cx="11192000" cy="760000"/>
           </a:xfrm>
           <a:prstGeom prst="rect">
@@ -807,7 +806,7 @@
         <p:spPr>
           <a:xfrm>
             <a:off x="500000" y="1300000"/>
-            <a:ext cx="5500000" cy="5158000"/>
+            <a:ext cx="5300000" cy="5158000"/>
           </a:xfrm>
           <a:prstGeom prst="rect">
             <a:avLst/>
@@ -868,8 +867,8 @@
         </p:nvSpPr>
         <p:spPr>
           <a:xfrm>
-            <a:off x="6250000" y="1300000"/>
-            <a:ext cx="5400000" cy="4700000"/>
+            <a:off x="6050000" y="1250000"/>
+            <a:ext cx="5650000" cy="5050000"/>
           </a:xfrm>
           <a:prstGeom prst="rect">
             <a:avLst/>
@@ -988,7 +987,7 @@
         </p:nvSpPr>
         <p:spPr>
           <a:xfrm>
-            <a:off x="500000" y="380000"/>
+            <a:off x="500000" y="360000"/>
             <a:ext cx="11192000" cy="760000"/>
           </a:xfrm>
           <a:prstGeom prst="rect">
@@ -1025,7 +1024,7 @@
         <p:spPr>
           <a:xfrm>
             <a:off x="500000" y="1300000"/>
-            <a:ext cx="5500000" cy="5158000"/>
+            <a:ext cx="5300000" cy="5158000"/>
           </a:xfrm>
           <a:prstGeom prst="rect">
             <a:avLst/>
@@ -1086,8 +1085,8 @@
         </p:nvSpPr>
         <p:spPr>
           <a:xfrm>
-            <a:off x="6250000" y="1300000"/>
-            <a:ext cx="5400000" cy="4700000"/>
+            <a:off x="6050000" y="1250000"/>
+            <a:ext cx="5650000" cy="5050000"/>
           </a:xfrm>
           <a:prstGeom prst="rect">
             <a:avLst/>
@@ -1292,7 +1291,7 @@
         </p:nvSpPr>
         <p:spPr>
           <a:xfrm>
-            <a:off x="500000" y="380000"/>
+            <a:off x="500000" y="360000"/>
             <a:ext cx="11192000" cy="760000"/>
           </a:xfrm>
           <a:prstGeom prst="rect">
@@ -1329,7 +1328,7 @@
         <p:spPr>
           <a:xfrm>
             <a:off x="500000" y="1300000"/>
-            <a:ext cx="5500000" cy="5158000"/>
+            <a:ext cx="5300000" cy="5158000"/>
           </a:xfrm>
           <a:prstGeom prst="rect">
             <a:avLst/>
@@ -1382,76 +1381,35 @@
           </a:p>
         </p:txBody>
       </p:sp>
-      <p:sp>
-        <p:nvSpPr>
-          <p:cNvPr id="5" name="placeholder"/>
-          <p:cNvSpPr/>
-          <p:nvPr/>
-        </p:nvSpPr>
-        <p:spPr>
-          <a:xfrm>
-            <a:off x="6250000" y="1300000"/>
-            <a:ext cx="5400000" cy="4700000"/>
-          </a:xfrm>
-          <a:prstGeom prst="rect">
-            <a:avLst/>
-          </a:prstGeom>
-          <a:solidFill>
-            <a:srgbClr val="F4F4F4"/>
-          </a:solidFill>
-          <a:ln w="19050">
+      <p:pic>
+        <p:nvPicPr>
+          <p:cNvPr id="5" name="img5"/>
+          <p:cNvPicPr>
+            <a:picLocks noChangeAspect="1"/>
+          </p:cNvPicPr>
+          <p:nvPr/>
+        </p:nvPicPr>
+        <p:blipFill>
+          <a:blip r:embed="rIdImg"/>
+          <a:stretch>
+            <a:fillRect/>
+          </a:stretch>
+        </p:blipFill>
+        <p:spPr>
+          <a:xfrm>
+            <a:off x="6050000" y="1911285"/>
+            <a:ext cx="5650000" cy="3727430"/>
+          </a:xfrm>
+          <a:prstGeom prst="rect">
+            <a:avLst/>
+          </a:prstGeom>
+          <a:ln w="9525">
             <a:solidFill>
-              <a:srgbClr val="BBBBBB"/>
+              <a:srgbClr val="DDDDDD"/>
             </a:solidFill>
-            <a:prstDash val="dash"/>
           </a:ln>
         </p:spPr>
-        <p:txBody>
-          <a:bodyPr anchor="ctr">
-            <a:normAutofit/>
-          </a:bodyPr>
-          <a:lstStyle/>
-          <a:p>
-            <a:pPr marL="0" indent="0" algn="ctr">
-              <a:buNone/>
-            </a:pPr>
-            <a:r>
-              <a:rPr lang="fr-FR" sz="1600" b="1">
-                <a:solidFill>
-                  <a:srgbClr val="888888"/>
-                </a:solidFill>
-              </a:rPr>
-              <a:t>📷 Capture</a:t>
-            </a:r>
-          </a:p>
-          <a:p>
-            <a:pPr marL="0" indent="0" algn="ctr">
-              <a:buNone/>
-            </a:pPr>
-            <a:r>
-              <a:rPr lang="fr-FR" sz="1300">
-                <a:solidFill>
-                  <a:srgbClr val="888888"/>
-                </a:solidFill>
-              </a:rPr>
-              <a:t>Tableau de bord conseiller</a:t>
-            </a:r>
-          </a:p>
-          <a:p>
-            <a:pPr marL="0" indent="0" algn="ctr">
-              <a:buNone/>
-            </a:pPr>
-            <a:r>
-              <a:rPr lang="fr-FR" sz="1100">
-                <a:solidFill>
-                  <a:srgbClr val="AAAAAA"/>
-                </a:solidFill>
-              </a:rPr>
-              <a:t>(insérer la copie d’écran ici)</a:t>
-            </a:r>
-          </a:p>
-        </p:txBody>
-      </p:sp>
+      </p:pic>
     </p:spTree>
   </p:cSld>
   <p:clrMapOvr>
@@ -1510,7 +1468,7 @@
         </p:nvSpPr>
         <p:spPr>
           <a:xfrm>
-            <a:off x="500000" y="380000"/>
+            <a:off x="500000" y="360000"/>
             <a:ext cx="11192000" cy="760000"/>
           </a:xfrm>
           <a:prstGeom prst="rect">
@@ -1547,7 +1505,7 @@
         <p:spPr>
           <a:xfrm>
             <a:off x="500000" y="1300000"/>
-            <a:ext cx="5500000" cy="5158000"/>
+            <a:ext cx="5300000" cy="5158000"/>
           </a:xfrm>
           <a:prstGeom prst="rect">
             <a:avLst/>
@@ -1608,8 +1566,8 @@
         </p:nvSpPr>
         <p:spPr>
           <a:xfrm>
-            <a:off x="6250000" y="1300000"/>
-            <a:ext cx="5400000" cy="4700000"/>
+            <a:off x="6050000" y="1250000"/>
+            <a:ext cx="5650000" cy="5050000"/>
           </a:xfrm>
           <a:prstGeom prst="rect">
             <a:avLst/>
@@ -1728,7 +1686,7 @@
         </p:nvSpPr>
         <p:spPr>
           <a:xfrm>
-            <a:off x="500000" y="380000"/>
+            <a:off x="500000" y="360000"/>
             <a:ext cx="11192000" cy="760000"/>
           </a:xfrm>
           <a:prstGeom prst="rect">
@@ -1765,7 +1723,7 @@
         <p:spPr>
           <a:xfrm>
             <a:off x="500000" y="1300000"/>
-            <a:ext cx="5500000" cy="5158000"/>
+            <a:ext cx="5300000" cy="5158000"/>
           </a:xfrm>
           <a:prstGeom prst="rect">
             <a:avLst/>
@@ -1826,8 +1784,8 @@
         </p:nvSpPr>
         <p:spPr>
           <a:xfrm>
-            <a:off x="6250000" y="1300000"/>
-            <a:ext cx="5400000" cy="4700000"/>
+            <a:off x="6050000" y="1250000"/>
+            <a:ext cx="5650000" cy="5050000"/>
           </a:xfrm>
           <a:prstGeom prst="rect">
             <a:avLst/>
@@ -2032,7 +1990,7 @@
         </p:nvSpPr>
         <p:spPr>
           <a:xfrm>
-            <a:off x="500000" y="380000"/>
+            <a:off x="500000" y="360000"/>
             <a:ext cx="11192000" cy="760000"/>
           </a:xfrm>
           <a:prstGeom prst="rect">
@@ -2069,7 +2027,7 @@
         <p:spPr>
           <a:xfrm>
             <a:off x="500000" y="1300000"/>
-            <a:ext cx="5500000" cy="5158000"/>
+            <a:ext cx="5300000" cy="5158000"/>
           </a:xfrm>
           <a:prstGeom prst="rect">
             <a:avLst/>
@@ -2122,76 +2080,35 @@
           </a:p>
         </p:txBody>
       </p:sp>
-      <p:sp>
-        <p:nvSpPr>
-          <p:cNvPr id="5" name="placeholder"/>
-          <p:cNvSpPr/>
-          <p:nvPr/>
-        </p:nvSpPr>
-        <p:spPr>
-          <a:xfrm>
-            <a:off x="6250000" y="1300000"/>
-            <a:ext cx="5400000" cy="4700000"/>
-          </a:xfrm>
-          <a:prstGeom prst="rect">
-            <a:avLst/>
-          </a:prstGeom>
-          <a:solidFill>
-            <a:srgbClr val="F4F4F4"/>
-          </a:solidFill>
-          <a:ln w="19050">
+      <p:pic>
+        <p:nvPicPr>
+          <p:cNvPr id="5" name="img5"/>
+          <p:cNvPicPr>
+            <a:picLocks noChangeAspect="1"/>
+          </p:cNvPicPr>
+          <p:nvPr/>
+        </p:nvPicPr>
+        <p:blipFill>
+          <a:blip r:embed="rIdImg"/>
+          <a:stretch>
+            <a:fillRect/>
+          </a:stretch>
+        </p:blipFill>
+        <p:spPr>
+          <a:xfrm>
+            <a:off x="7639362" y="1250000"/>
+            <a:ext cx="2471276" cy="5050000"/>
+          </a:xfrm>
+          <a:prstGeom prst="rect">
+            <a:avLst/>
+          </a:prstGeom>
+          <a:ln w="9525">
             <a:solidFill>
-              <a:srgbClr val="BBBBBB"/>
+              <a:srgbClr val="DDDDDD"/>
             </a:solidFill>
-            <a:prstDash val="dash"/>
           </a:ln>
         </p:spPr>
-        <p:txBody>
-          <a:bodyPr anchor="ctr">
-            <a:normAutofit/>
-          </a:bodyPr>
-          <a:lstStyle/>
-          <a:p>
-            <a:pPr marL="0" indent="0" algn="ctr">
-              <a:buNone/>
-            </a:pPr>
-            <a:r>
-              <a:rPr lang="fr-FR" sz="1600" b="1">
-                <a:solidFill>
-                  <a:srgbClr val="888888"/>
-                </a:solidFill>
-              </a:rPr>
-              <a:t>📷 Capture</a:t>
-            </a:r>
-          </a:p>
-          <a:p>
-            <a:pPr marL="0" indent="0" algn="ctr">
-              <a:buNone/>
-            </a:pPr>
-            <a:r>
-              <a:rPr lang="fr-FR" sz="1300">
-                <a:solidFill>
-                  <a:srgbClr val="888888"/>
-                </a:solidFill>
-              </a:rPr>
-              <a:t>Recherche imprimeur + résultats</a:t>
-            </a:r>
-          </a:p>
-          <a:p>
-            <a:pPr marL="0" indent="0" algn="ctr">
-              <a:buNone/>
-            </a:pPr>
-            <a:r>
-              <a:rPr lang="fr-FR" sz="1100">
-                <a:solidFill>
-                  <a:srgbClr val="AAAAAA"/>
-                </a:solidFill>
-              </a:rPr>
-              <a:t>(insérer la copie d’écran ici)</a:t>
-            </a:r>
-          </a:p>
-        </p:txBody>
-      </p:sp>
+      </p:pic>
     </p:spTree>
   </p:cSld>
   <p:clrMapOvr>
@@ -2336,7 +2253,7 @@
         </p:nvSpPr>
         <p:spPr>
           <a:xfrm>
-            <a:off x="500000" y="380000"/>
+            <a:off x="500000" y="360000"/>
             <a:ext cx="11192000" cy="760000"/>
           </a:xfrm>
           <a:prstGeom prst="rect">
@@ -2373,7 +2290,7 @@
         <p:spPr>
           <a:xfrm>
             <a:off x="500000" y="1300000"/>
-            <a:ext cx="5500000" cy="5158000"/>
+            <a:ext cx="5300000" cy="5158000"/>
           </a:xfrm>
           <a:prstGeom prst="rect">
             <a:avLst/>
@@ -2426,76 +2343,35 @@
           </a:p>
         </p:txBody>
       </p:sp>
-      <p:sp>
-        <p:nvSpPr>
-          <p:cNvPr id="5" name="placeholder"/>
-          <p:cNvSpPr/>
-          <p:nvPr/>
-        </p:nvSpPr>
-        <p:spPr>
-          <a:xfrm>
-            <a:off x="6250000" y="1300000"/>
-            <a:ext cx="5400000" cy="4700000"/>
-          </a:xfrm>
-          <a:prstGeom prst="rect">
-            <a:avLst/>
-          </a:prstGeom>
-          <a:solidFill>
-            <a:srgbClr val="F4F4F4"/>
-          </a:solidFill>
-          <a:ln w="19050">
+      <p:pic>
+        <p:nvPicPr>
+          <p:cNvPr id="5" name="img5"/>
+          <p:cNvPicPr>
+            <a:picLocks noChangeAspect="1"/>
+          </p:cNvPicPr>
+          <p:nvPr/>
+        </p:nvPicPr>
+        <p:blipFill>
+          <a:blip r:embed="rIdImg"/>
+          <a:stretch>
+            <a:fillRect/>
+          </a:stretch>
+        </p:blipFill>
+        <p:spPr>
+          <a:xfrm>
+            <a:off x="7639362" y="1250000"/>
+            <a:ext cx="2471276" cy="5050000"/>
+          </a:xfrm>
+          <a:prstGeom prst="rect">
+            <a:avLst/>
+          </a:prstGeom>
+          <a:ln w="9525">
             <a:solidFill>
-              <a:srgbClr val="BBBBBB"/>
+              <a:srgbClr val="DDDDDD"/>
             </a:solidFill>
-            <a:prstDash val="dash"/>
           </a:ln>
         </p:spPr>
-        <p:txBody>
-          <a:bodyPr anchor="ctr">
-            <a:normAutofit/>
-          </a:bodyPr>
-          <a:lstStyle/>
-          <a:p>
-            <a:pPr marL="0" indent="0" algn="ctr">
-              <a:buNone/>
-            </a:pPr>
-            <a:r>
-              <a:rPr lang="fr-FR" sz="1600" b="1">
-                <a:solidFill>
-                  <a:srgbClr val="888888"/>
-                </a:solidFill>
-              </a:rPr>
-              <a:t>📷 Capture</a:t>
-            </a:r>
-          </a:p>
-          <a:p>
-            <a:pPr marL="0" indent="0" algn="ctr">
-              <a:buNone/>
-            </a:pPr>
-            <a:r>
-              <a:rPr lang="fr-FR" sz="1300">
-                <a:solidFill>
-                  <a:srgbClr val="888888"/>
-                </a:solidFill>
-              </a:rPr>
-              <a:t>Fiche complète du dossier</a:t>
-            </a:r>
-          </a:p>
-          <a:p>
-            <a:pPr marL="0" indent="0" algn="ctr">
-              <a:buNone/>
-            </a:pPr>
-            <a:r>
-              <a:rPr lang="fr-FR" sz="1100">
-                <a:solidFill>
-                  <a:srgbClr val="AAAAAA"/>
-                </a:solidFill>
-              </a:rPr>
-              <a:t>(insérer la copie d’écran ici)</a:t>
-            </a:r>
-          </a:p>
-        </p:txBody>
-      </p:sp>
+      </p:pic>
     </p:spTree>
   </p:cSld>
   <p:clrMapOvr>
@@ -2554,7 +2430,7 @@
         </p:nvSpPr>
         <p:spPr>
           <a:xfrm>
-            <a:off x="500000" y="380000"/>
+            <a:off x="500000" y="360000"/>
             <a:ext cx="11192000" cy="760000"/>
           </a:xfrm>
           <a:prstGeom prst="rect">
@@ -2591,7 +2467,7 @@
         <p:spPr>
           <a:xfrm>
             <a:off x="500000" y="1300000"/>
-            <a:ext cx="5500000" cy="5158000"/>
+            <a:ext cx="5300000" cy="5158000"/>
           </a:xfrm>
           <a:prstGeom prst="rect">
             <a:avLst/>
@@ -2652,8 +2528,8 @@
         </p:nvSpPr>
         <p:spPr>
           <a:xfrm>
-            <a:off x="6250000" y="1300000"/>
-            <a:ext cx="5400000" cy="4700000"/>
+            <a:off x="6050000" y="1250000"/>
+            <a:ext cx="5650000" cy="5050000"/>
           </a:xfrm>
           <a:prstGeom prst="rect">
             <a:avLst/>
@@ -2772,7 +2648,7 @@
         </p:nvSpPr>
         <p:spPr>
           <a:xfrm>
-            <a:off x="500000" y="380000"/>
+            <a:off x="500000" y="360000"/>
             <a:ext cx="11192000" cy="760000"/>
           </a:xfrm>
           <a:prstGeom prst="rect">
@@ -2809,7 +2685,7 @@
         <p:spPr>
           <a:xfrm>
             <a:off x="500000" y="1300000"/>
-            <a:ext cx="5500000" cy="5158000"/>
+            <a:ext cx="5300000" cy="5158000"/>
           </a:xfrm>
           <a:prstGeom prst="rect">
             <a:avLst/>
@@ -2870,8 +2746,8 @@
         </p:nvSpPr>
         <p:spPr>
           <a:xfrm>
-            <a:off x="6250000" y="1300000"/>
-            <a:ext cx="5400000" cy="4700000"/>
+            <a:off x="6050000" y="1250000"/>
+            <a:ext cx="5650000" cy="5050000"/>
           </a:xfrm>
           <a:prstGeom prst="rect">
             <a:avLst/>
@@ -3076,7 +2952,7 @@
         </p:nvSpPr>
         <p:spPr>
           <a:xfrm>
-            <a:off x="500000" y="380000"/>
+            <a:off x="500000" y="360000"/>
             <a:ext cx="11192000" cy="760000"/>
           </a:xfrm>
           <a:prstGeom prst="rect">
@@ -3113,7 +2989,7 @@
         <p:spPr>
           <a:xfrm>
             <a:off x="500000" y="1300000"/>
-            <a:ext cx="5500000" cy="5158000"/>
+            <a:ext cx="5300000" cy="5158000"/>
           </a:xfrm>
           <a:prstGeom prst="rect">
             <a:avLst/>
@@ -3166,76 +3042,35 @@
           </a:p>
         </p:txBody>
       </p:sp>
-      <p:sp>
-        <p:nvSpPr>
-          <p:cNvPr id="5" name="placeholder"/>
-          <p:cNvSpPr/>
-          <p:nvPr/>
-        </p:nvSpPr>
-        <p:spPr>
-          <a:xfrm>
-            <a:off x="6250000" y="1300000"/>
-            <a:ext cx="5400000" cy="4700000"/>
-          </a:xfrm>
-          <a:prstGeom prst="rect">
-            <a:avLst/>
-          </a:prstGeom>
-          <a:solidFill>
-            <a:srgbClr val="F4F4F4"/>
-          </a:solidFill>
-          <a:ln w="19050">
+      <p:pic>
+        <p:nvPicPr>
+          <p:cNvPr id="5" name="img5"/>
+          <p:cNvPicPr>
+            <a:picLocks noChangeAspect="1"/>
+          </p:cNvPicPr>
+          <p:nvPr/>
+        </p:nvPicPr>
+        <p:blipFill>
+          <a:blip r:embed="rIdImg"/>
+          <a:stretch>
+            <a:fillRect/>
+          </a:stretch>
+        </p:blipFill>
+        <p:spPr>
+          <a:xfrm>
+            <a:off x="6050000" y="1911285"/>
+            <a:ext cx="5650000" cy="3727430"/>
+          </a:xfrm>
+          <a:prstGeom prst="rect">
+            <a:avLst/>
+          </a:prstGeom>
+          <a:ln w="9525">
             <a:solidFill>
-              <a:srgbClr val="BBBBBB"/>
+              <a:srgbClr val="DDDDDD"/>
             </a:solidFill>
-            <a:prstDash val="dash"/>
           </a:ln>
         </p:spPr>
-        <p:txBody>
-          <a:bodyPr anchor="ctr">
-            <a:normAutofit/>
-          </a:bodyPr>
-          <a:lstStyle/>
-          <a:p>
-            <a:pPr marL="0" indent="0" algn="ctr">
-              <a:buNone/>
-            </a:pPr>
-            <a:r>
-              <a:rPr lang="fr-FR" sz="1600" b="1">
-                <a:solidFill>
-                  <a:srgbClr val="888888"/>
-                </a:solidFill>
-              </a:rPr>
-              <a:t>📷 Capture</a:t>
-            </a:r>
-          </a:p>
-          <a:p>
-            <a:pPr marL="0" indent="0" algn="ctr">
-              <a:buNone/>
-            </a:pPr>
-            <a:r>
-              <a:rPr lang="fr-FR" sz="1300">
-                <a:solidFill>
-                  <a:srgbClr val="888888"/>
-                </a:solidFill>
-              </a:rPr>
-              <a:t>Tableau de bord — KPI</a:t>
-            </a:r>
-          </a:p>
-          <a:p>
-            <a:pPr marL="0" indent="0" algn="ctr">
-              <a:buNone/>
-            </a:pPr>
-            <a:r>
-              <a:rPr lang="fr-FR" sz="1100">
-                <a:solidFill>
-                  <a:srgbClr val="AAAAAA"/>
-                </a:solidFill>
-              </a:rPr>
-              <a:t>(insérer la copie d’écran ici)</a:t>
-            </a:r>
-          </a:p>
-        </p:txBody>
-      </p:sp>
+      </p:pic>
     </p:spTree>
   </p:cSld>
   <p:clrMapOvr>
@@ -3294,7 +3129,7 @@
         </p:nvSpPr>
         <p:spPr>
           <a:xfrm>
-            <a:off x="500000" y="380000"/>
+            <a:off x="500000" y="360000"/>
             <a:ext cx="11192000" cy="760000"/>
           </a:xfrm>
           <a:prstGeom prst="rect">
@@ -3331,7 +3166,7 @@
         <p:spPr>
           <a:xfrm>
             <a:off x="500000" y="1300000"/>
-            <a:ext cx="5500000" cy="5158000"/>
+            <a:ext cx="5300000" cy="5158000"/>
           </a:xfrm>
           <a:prstGeom prst="rect">
             <a:avLst/>
@@ -3384,76 +3219,35 @@
           </a:p>
         </p:txBody>
       </p:sp>
-      <p:sp>
-        <p:nvSpPr>
-          <p:cNvPr id="5" name="placeholder"/>
-          <p:cNvSpPr/>
-          <p:nvPr/>
-        </p:nvSpPr>
-        <p:spPr>
-          <a:xfrm>
-            <a:off x="6250000" y="1300000"/>
-            <a:ext cx="5400000" cy="4700000"/>
-          </a:xfrm>
-          <a:prstGeom prst="rect">
-            <a:avLst/>
-          </a:prstGeom>
-          <a:solidFill>
-            <a:srgbClr val="F4F4F4"/>
-          </a:solidFill>
-          <a:ln w="19050">
+      <p:pic>
+        <p:nvPicPr>
+          <p:cNvPr id="5" name="img5"/>
+          <p:cNvPicPr>
+            <a:picLocks noChangeAspect="1"/>
+          </p:cNvPicPr>
+          <p:nvPr/>
+        </p:nvPicPr>
+        <p:blipFill>
+          <a:blip r:embed="rIdImg"/>
+          <a:stretch>
+            <a:fillRect/>
+          </a:stretch>
+        </p:blipFill>
+        <p:spPr>
+          <a:xfrm>
+            <a:off x="6050000" y="1911285"/>
+            <a:ext cx="5650000" cy="3727430"/>
+          </a:xfrm>
+          <a:prstGeom prst="rect">
+            <a:avLst/>
+          </a:prstGeom>
+          <a:ln w="9525">
             <a:solidFill>
-              <a:srgbClr val="BBBBBB"/>
+              <a:srgbClr val="DDDDDD"/>
             </a:solidFill>
-            <a:prstDash val="dash"/>
           </a:ln>
         </p:spPr>
-        <p:txBody>
-          <a:bodyPr anchor="ctr">
-            <a:normAutofit/>
-          </a:bodyPr>
-          <a:lstStyle/>
-          <a:p>
-            <a:pPr marL="0" indent="0" algn="ctr">
-              <a:buNone/>
-            </a:pPr>
-            <a:r>
-              <a:rPr lang="fr-FR" sz="1600" b="1">
-                <a:solidFill>
-                  <a:srgbClr val="888888"/>
-                </a:solidFill>
-              </a:rPr>
-              <a:t>📷 Capture</a:t>
-            </a:r>
-          </a:p>
-          <a:p>
-            <a:pPr marL="0" indent="0" algn="ctr">
-              <a:buNone/>
-            </a:pPr>
-            <a:r>
-              <a:rPr lang="fr-FR" sz="1300">
-                <a:solidFill>
-                  <a:srgbClr val="888888"/>
-                </a:solidFill>
-              </a:rPr>
-              <a:t>Configuration carte</a:t>
-            </a:r>
-          </a:p>
-          <a:p>
-            <a:pPr marL="0" indent="0" algn="ctr">
-              <a:buNone/>
-            </a:pPr>
-            <a:r>
-              <a:rPr lang="fr-FR" sz="1100">
-                <a:solidFill>
-                  <a:srgbClr val="AAAAAA"/>
-                </a:solidFill>
-              </a:rPr>
-              <a:t>(insérer la copie d’écran ici)</a:t>
-            </a:r>
-          </a:p>
-        </p:txBody>
-      </p:sp>
+      </p:pic>
     </p:spTree>
   </p:cSld>
   <p:clrMapOvr>
@@ -3512,7 +3306,7 @@
         </p:nvSpPr>
         <p:spPr>
           <a:xfrm>
-            <a:off x="500000" y="380000"/>
+            <a:off x="500000" y="360000"/>
             <a:ext cx="11192000" cy="760000"/>
           </a:xfrm>
           <a:prstGeom prst="rect">
@@ -3535,7 +3329,7 @@
                   <a:srgbClr val="9B0F1E"/>
                 </a:solidFill>
               </a:rPr>
-              <a:t>Utilisateurs — créer un compte</a:t>
+              <a:t>Utilisateurs (création &amp; import)</a:t>
             </a:r>
           </a:p>
         </p:txBody>
@@ -3549,7 +3343,7 @@
         <p:spPr>
           <a:xfrm>
             <a:off x="500000" y="1300000"/>
-            <a:ext cx="5500000" cy="5158000"/>
+            <a:ext cx="5300000" cy="5158000"/>
           </a:xfrm>
           <a:prstGeom prst="rect">
             <a:avLst/>
@@ -3571,107 +3365,66 @@
                   <a:srgbClr val="1E1416"/>
                 </a:solidFill>
               </a:rPr>
-              <a:t>Renseigner nom, e-mail, rôle, mot de passe.</a:t>
-            </a:r>
-          </a:p>
-          <a:p>
-            <a:pPr marL="228600" indent="-228600" algn="l">
-              <a:buChar char="•"/>
-            </a:pPr>
-            <a:r>
-              <a:rPr lang="fr-FR" sz="1500">
-                <a:solidFill>
-                  <a:srgbClr val="1E1416"/>
-                </a:solidFill>
-              </a:rPr>
-              <a:t>Pour un conseiller : agence + téléphone (9 chiffres) obligatoires.</a:t>
-            </a:r>
-          </a:p>
-          <a:p>
-            <a:pPr marL="228600" indent="-228600" algn="l">
-              <a:buChar char="•"/>
-            </a:pPr>
-            <a:r>
-              <a:rPr lang="fr-FR" sz="1500">
-                <a:solidFill>
-                  <a:srgbClr val="1E1416"/>
-                </a:solidFill>
-              </a:rPr>
-              <a:t>La liste des comptes existants est affichée en dessous.</a:t>
-            </a:r>
-          </a:p>
-        </p:txBody>
-      </p:sp>
-      <p:sp>
-        <p:nvSpPr>
-          <p:cNvPr id="5" name="placeholder"/>
-          <p:cNvSpPr/>
-          <p:nvPr/>
-        </p:nvSpPr>
-        <p:spPr>
-          <a:xfrm>
-            <a:off x="6250000" y="1300000"/>
-            <a:ext cx="5400000" cy="4700000"/>
-          </a:xfrm>
-          <a:prstGeom prst="rect">
-            <a:avLst/>
-          </a:prstGeom>
-          <a:solidFill>
-            <a:srgbClr val="F4F4F4"/>
-          </a:solidFill>
-          <a:ln w="19050">
+              <a:t>Créer un compte (nom, e-mail, rôle, mot de passe ; agence + téléphone pour un conseiller).</a:t>
+            </a:r>
+          </a:p>
+          <a:p>
+            <a:pPr marL="228600" indent="-228600" algn="l">
+              <a:buChar char="•"/>
+            </a:pPr>
+            <a:r>
+              <a:rPr lang="fr-FR" sz="1500">
+                <a:solidFill>
+                  <a:srgbClr val="1E1416"/>
+                </a:solidFill>
+              </a:rPr>
+              <a:t>Import en masse : CSV ou coller un tableau ; aperçu Nouveau / Doublon / Invalide.</a:t>
+            </a:r>
+          </a:p>
+          <a:p>
+            <a:pPr marL="228600" indent="-228600" algn="l">
+              <a:buChar char="•"/>
+            </a:pPr>
+            <a:r>
+              <a:rPr lang="fr-FR" sz="1500">
+                <a:solidFill>
+                  <a:srgbClr val="1E1416"/>
+                </a:solidFill>
+              </a:rPr>
+              <a:t>Doublons : ignorer ou mettre à jour ; mots de passe temporaires générés + export CSV.</a:t>
+            </a:r>
+          </a:p>
+        </p:txBody>
+      </p:sp>
+      <p:pic>
+        <p:nvPicPr>
+          <p:cNvPr id="5" name="img5"/>
+          <p:cNvPicPr>
+            <a:picLocks noChangeAspect="1"/>
+          </p:cNvPicPr>
+          <p:nvPr/>
+        </p:nvPicPr>
+        <p:blipFill>
+          <a:blip r:embed="rIdImg"/>
+          <a:stretch>
+            <a:fillRect/>
+          </a:stretch>
+        </p:blipFill>
+        <p:spPr>
+          <a:xfrm>
+            <a:off x="6050000" y="1911285"/>
+            <a:ext cx="5650000" cy="3727430"/>
+          </a:xfrm>
+          <a:prstGeom prst="rect">
+            <a:avLst/>
+          </a:prstGeom>
+          <a:ln w="9525">
             <a:solidFill>
-              <a:srgbClr val="BBBBBB"/>
+              <a:srgbClr val="DDDDDD"/>
             </a:solidFill>
-            <a:prstDash val="dash"/>
           </a:ln>
         </p:spPr>
-        <p:txBody>
-          <a:bodyPr anchor="ctr">
-            <a:normAutofit/>
-          </a:bodyPr>
-          <a:lstStyle/>
-          <a:p>
-            <a:pPr marL="0" indent="0" algn="ctr">
-              <a:buNone/>
-            </a:pPr>
-            <a:r>
-              <a:rPr lang="fr-FR" sz="1600" b="1">
-                <a:solidFill>
-                  <a:srgbClr val="888888"/>
-                </a:solidFill>
-              </a:rPr>
-              <a:t>📷 Capture</a:t>
-            </a:r>
-          </a:p>
-          <a:p>
-            <a:pPr marL="0" indent="0" algn="ctr">
-              <a:buNone/>
-            </a:pPr>
-            <a:r>
-              <a:rPr lang="fr-FR" sz="1300">
-                <a:solidFill>
-                  <a:srgbClr val="888888"/>
-                </a:solidFill>
-              </a:rPr>
-              <a:t>Création d'un utilisateur</a:t>
-            </a:r>
-          </a:p>
-          <a:p>
-            <a:pPr marL="0" indent="0" algn="ctr">
-              <a:buNone/>
-            </a:pPr>
-            <a:r>
-              <a:rPr lang="fr-FR" sz="1100">
-                <a:solidFill>
-                  <a:srgbClr val="AAAAAA"/>
-                </a:solidFill>
-              </a:rPr>
-              <a:t>(insérer la copie d’écran ici)</a:t>
-            </a:r>
-          </a:p>
-        </p:txBody>
-      </p:sp>
+      </p:pic>
     </p:spTree>
   </p:cSld>
   <p:clrMapOvr>
@@ -3730,7 +3483,7 @@
         </p:nvSpPr>
         <p:spPr>
           <a:xfrm>
-            <a:off x="500000" y="380000"/>
+            <a:off x="500000" y="360000"/>
             <a:ext cx="11192000" cy="760000"/>
           </a:xfrm>
           <a:prstGeom prst="rect">
@@ -3753,7 +3506,7 @@
                   <a:srgbClr val="9B0F1E"/>
                 </a:solidFill>
               </a:rPr>
-              <a:t>Utilisateurs — import en masse</a:t>
+              <a:t>Historique des paiements</a:t>
             </a:r>
           </a:p>
         </p:txBody>
@@ -3767,7 +3520,7 @@
         <p:spPr>
           <a:xfrm>
             <a:off x="500000" y="1300000"/>
-            <a:ext cx="5500000" cy="5158000"/>
+            <a:ext cx="5300000" cy="5158000"/>
           </a:xfrm>
           <a:prstGeom prst="rect">
             <a:avLst/>
@@ -3789,120 +3542,66 @@
                   <a:srgbClr val="1E1416"/>
                 </a:solidFill>
               </a:rPr>
-              <a:t>Charger un fichier CSV (modèle téléchargeable) OU coller un tableau Excel.</a:t>
-            </a:r>
-          </a:p>
-          <a:p>
-            <a:pPr marL="228600" indent="-228600" algn="l">
-              <a:buChar char="•"/>
-            </a:pPr>
-            <a:r>
-              <a:rPr lang="fr-FR" sz="1500">
-                <a:solidFill>
-                  <a:srgbClr val="1E1416"/>
-                </a:solidFill>
-              </a:rPr>
-              <a:t>Aperçu : chaque ligne étiquetée Nouveau / Doublon / Invalide.</a:t>
-            </a:r>
-          </a:p>
-          <a:p>
-            <a:pPr marL="228600" indent="-228600" algn="l">
-              <a:buChar char="•"/>
-            </a:pPr>
-            <a:r>
-              <a:rPr lang="fr-FR" sz="1500">
-                <a:solidFill>
-                  <a:srgbClr val="1E1416"/>
-                </a:solidFill>
-              </a:rPr>
-              <a:t>Choisir « Ignorer les doublons » ou « Mettre à jour », puis « Importer ».</a:t>
-            </a:r>
-          </a:p>
-          <a:p>
-            <a:pPr marL="228600" indent="-228600" algn="l">
-              <a:buChar char="•"/>
-            </a:pPr>
-            <a:r>
-              <a:rPr lang="fr-FR" sz="1500">
-                <a:solidFill>
-                  <a:srgbClr val="1E1416"/>
-                </a:solidFill>
-              </a:rPr>
-              <a:t>Mots de passe temporaires générés + export CSV des identifiants à communiquer.</a:t>
-            </a:r>
-          </a:p>
-        </p:txBody>
-      </p:sp>
-      <p:sp>
-        <p:nvSpPr>
-          <p:cNvPr id="5" name="placeholder"/>
-          <p:cNvSpPr/>
-          <p:nvPr/>
-        </p:nvSpPr>
-        <p:spPr>
-          <a:xfrm>
-            <a:off x="6250000" y="1300000"/>
-            <a:ext cx="5400000" cy="4700000"/>
-          </a:xfrm>
-          <a:prstGeom prst="rect">
-            <a:avLst/>
-          </a:prstGeom>
-          <a:solidFill>
-            <a:srgbClr val="F4F4F4"/>
-          </a:solidFill>
-          <a:ln w="19050">
+              <a:t>Tableau détaillé : Photo · Client · Téléphone · CNI · Date · Paiement · Montant · Statut.</a:t>
+            </a:r>
+          </a:p>
+          <a:p>
+            <a:pPr marL="228600" indent="-228600" algn="l">
+              <a:buChar char="•"/>
+            </a:pPr>
+            <a:r>
+              <a:rPr lang="fr-FR" sz="1500">
+                <a:solidFill>
+                  <a:srgbClr val="1E1416"/>
+                </a:solidFill>
+              </a:rPr>
+              <a:t>Filtres (recherche, statut, conseiller, dates) + chip rapide « Échouées ».</a:t>
+            </a:r>
+          </a:p>
+          <a:p>
+            <a:pPr marL="228600" indent="-228600" algn="l">
+              <a:buChar char="•"/>
+            </a:pPr>
+            <a:r>
+              <a:rPr lang="fr-FR" sz="1500">
+                <a:solidFill>
+                  <a:srgbClr val="1E1416"/>
+                </a:solidFill>
+              </a:rPr>
+              <a:t>Pagination ; clic sur une ligne = détail complet ; export CSV.</a:t>
+            </a:r>
+          </a:p>
+        </p:txBody>
+      </p:sp>
+      <p:pic>
+        <p:nvPicPr>
+          <p:cNvPr id="5" name="img5"/>
+          <p:cNvPicPr>
+            <a:picLocks noChangeAspect="1"/>
+          </p:cNvPicPr>
+          <p:nvPr/>
+        </p:nvPicPr>
+        <p:blipFill>
+          <a:blip r:embed="rIdImg"/>
+          <a:stretch>
+            <a:fillRect/>
+          </a:stretch>
+        </p:blipFill>
+        <p:spPr>
+          <a:xfrm>
+            <a:off x="6050000" y="1911285"/>
+            <a:ext cx="5650000" cy="3727430"/>
+          </a:xfrm>
+          <a:prstGeom prst="rect">
+            <a:avLst/>
+          </a:prstGeom>
+          <a:ln w="9525">
             <a:solidFill>
-              <a:srgbClr val="BBBBBB"/>
+              <a:srgbClr val="DDDDDD"/>
             </a:solidFill>
-            <a:prstDash val="dash"/>
           </a:ln>
         </p:spPr>
-        <p:txBody>
-          <a:bodyPr anchor="ctr">
-            <a:normAutofit/>
-          </a:bodyPr>
-          <a:lstStyle/>
-          <a:p>
-            <a:pPr marL="0" indent="0" algn="ctr">
-              <a:buNone/>
-            </a:pPr>
-            <a:r>
-              <a:rPr lang="fr-FR" sz="1600" b="1">
-                <a:solidFill>
-                  <a:srgbClr val="888888"/>
-                </a:solidFill>
-              </a:rPr>
-              <a:t>📷 Capture</a:t>
-            </a:r>
-          </a:p>
-          <a:p>
-            <a:pPr marL="0" indent="0" algn="ctr">
-              <a:buNone/>
-            </a:pPr>
-            <a:r>
-              <a:rPr lang="fr-FR" sz="1300">
-                <a:solidFill>
-                  <a:srgbClr val="888888"/>
-                </a:solidFill>
-              </a:rPr>
-              <a:t>Import d'utilisateurs (aperçu)</a:t>
-            </a:r>
-          </a:p>
-          <a:p>
-            <a:pPr marL="0" indent="0" algn="ctr">
-              <a:buNone/>
-            </a:pPr>
-            <a:r>
-              <a:rPr lang="fr-FR" sz="1100">
-                <a:solidFill>
-                  <a:srgbClr val="AAAAAA"/>
-                </a:solidFill>
-              </a:rPr>
-              <a:t>(insérer la copie d’écran ici)</a:t>
-            </a:r>
-          </a:p>
-        </p:txBody>
-      </p:sp>
+      </p:pic>
     </p:spTree>
   </p:cSld>
   <p:clrMapOvr>
@@ -3943,7 +3642,7 @@
             <a:avLst/>
           </a:prstGeom>
           <a:solidFill>
-            <a:srgbClr val="FFFFFF"/>
+            <a:srgbClr val="9B0F1E"/>
           </a:solidFill>
         </p:spPr>
         <p:txBody>
@@ -3961,8 +3660,8 @@
         </p:nvSpPr>
         <p:spPr>
           <a:xfrm>
-            <a:off x="500000" y="380000"/>
-            <a:ext cx="11192000" cy="760000"/>
+            <a:off x="800000" y="2700000"/>
+            <a:ext cx="10592000" cy="1400000"/>
           </a:xfrm>
           <a:prstGeom prst="rect">
             <a:avLst/>
@@ -3970,7 +3669,7 @@
           <a:noFill/>
         </p:spPr>
         <p:txBody>
-          <a:bodyPr wrap="square" lIns="91440" tIns="68580" rIns="91440" bIns="68580" anchor="t">
+          <a:bodyPr wrap="square" lIns="91440" tIns="68580" rIns="91440" bIns="68580" anchor="ctr">
             <a:normAutofit/>
           </a:bodyPr>
           <a:lstStyle/>
@@ -3979,144 +3678,12 @@
               <a:buNone/>
             </a:pPr>
             <a:r>
-              <a:rPr lang="fr-FR" sz="2600" b="1">
-                <a:solidFill>
-                  <a:srgbClr val="9B0F1E"/>
-                </a:solidFill>
-              </a:rPr>
-              <a:t>Historique des paiements</a:t>
-            </a:r>
-          </a:p>
-        </p:txBody>
-      </p:sp>
-      <p:sp>
-        <p:nvSpPr>
-          <p:cNvPr id="4" name="body"/>
-          <p:cNvSpPr/>
-          <p:nvPr/>
-        </p:nvSpPr>
-        <p:spPr>
-          <a:xfrm>
-            <a:off x="500000" y="1300000"/>
-            <a:ext cx="5500000" cy="5158000"/>
-          </a:xfrm>
-          <a:prstGeom prst="rect">
-            <a:avLst/>
-          </a:prstGeom>
-          <a:noFill/>
-        </p:spPr>
-        <p:txBody>
-          <a:bodyPr wrap="square" lIns="91440" tIns="68580" rIns="91440" bIns="68580" anchor="t">
-            <a:normAutofit/>
-          </a:bodyPr>
-          <a:lstStyle/>
-          <a:p>
-            <a:pPr marL="228600" indent="-228600" algn="l">
-              <a:buChar char="•"/>
-            </a:pPr>
-            <a:r>
-              <a:rPr lang="fr-FR" sz="1500">
-                <a:solidFill>
-                  <a:srgbClr val="1E1416"/>
-                </a:solidFill>
-              </a:rPr>
-              <a:t>Tableau détaillé : Photo · Client · Téléphone · CNI · Date · Paiement · Montant · Statut.</a:t>
-            </a:r>
-          </a:p>
-          <a:p>
-            <a:pPr marL="228600" indent="-228600" algn="l">
-              <a:buChar char="•"/>
-            </a:pPr>
-            <a:r>
-              <a:rPr lang="fr-FR" sz="1500">
-                <a:solidFill>
-                  <a:srgbClr val="1E1416"/>
-                </a:solidFill>
-              </a:rPr>
-              <a:t>Filtres (recherche, statut, conseiller, dates) + chip rapide « Échouées ».</a:t>
-            </a:r>
-          </a:p>
-          <a:p>
-            <a:pPr marL="228600" indent="-228600" algn="l">
-              <a:buChar char="•"/>
-            </a:pPr>
-            <a:r>
-              <a:rPr lang="fr-FR" sz="1500">
-                <a:solidFill>
-                  <a:srgbClr val="1E1416"/>
-                </a:solidFill>
-              </a:rPr>
-              <a:t>Pagination ; clic sur une ligne = détail complet ; export CSV.</a:t>
-            </a:r>
-          </a:p>
-        </p:txBody>
-      </p:sp>
-      <p:sp>
-        <p:nvSpPr>
-          <p:cNvPr id="5" name="placeholder"/>
-          <p:cNvSpPr/>
-          <p:nvPr/>
-        </p:nvSpPr>
-        <p:spPr>
-          <a:xfrm>
-            <a:off x="6250000" y="1300000"/>
-            <a:ext cx="5400000" cy="4700000"/>
-          </a:xfrm>
-          <a:prstGeom prst="rect">
-            <a:avLst/>
-          </a:prstGeom>
-          <a:solidFill>
-            <a:srgbClr val="F4F4F4"/>
-          </a:solidFill>
-          <a:ln w="19050">
-            <a:solidFill>
-              <a:srgbClr val="BBBBBB"/>
-            </a:solidFill>
-            <a:prstDash val="dash"/>
-          </a:ln>
-        </p:spPr>
-        <p:txBody>
-          <a:bodyPr anchor="ctr">
-            <a:normAutofit/>
-          </a:bodyPr>
-          <a:lstStyle/>
-          <a:p>
-            <a:pPr marL="0" indent="0" algn="ctr">
-              <a:buNone/>
-            </a:pPr>
-            <a:r>
-              <a:rPr lang="fr-FR" sz="1600" b="1">
-                <a:solidFill>
-                  <a:srgbClr val="888888"/>
-                </a:solidFill>
-              </a:rPr>
-              <a:t>📷 Capture</a:t>
-            </a:r>
-          </a:p>
-          <a:p>
-            <a:pPr marL="0" indent="0" algn="ctr">
-              <a:buNone/>
-            </a:pPr>
-            <a:r>
-              <a:rPr lang="fr-FR" sz="1300">
-                <a:solidFill>
-                  <a:srgbClr val="888888"/>
-                </a:solidFill>
-              </a:rPr>
-              <a:t>Tableau des transactions</a:t>
-            </a:r>
-          </a:p>
-          <a:p>
-            <a:pPr marL="0" indent="0" algn="ctr">
-              <a:buNone/>
-            </a:pPr>
-            <a:r>
-              <a:rPr lang="fr-FR" sz="1100">
-                <a:solidFill>
-                  <a:srgbClr val="AAAAAA"/>
-                </a:solidFill>
-              </a:rPr>
-              <a:t>(insérer la copie d’écran ici)</a:t>
+              <a:rPr lang="fr-FR" sz="3600" b="1">
+                <a:solidFill>
+                  <a:srgbClr val="FFFFFF"/>
+                </a:solidFill>
+              </a:rPr>
+              <a:t>6. Repères — paiement &amp; statuts</a:t>
             </a:r>
           </a:p>
         </p:txBody>
@@ -4161,7 +3728,7 @@
             <a:avLst/>
           </a:prstGeom>
           <a:solidFill>
-            <a:srgbClr val="9B0F1E"/>
+            <a:srgbClr val="FFFFFF"/>
           </a:solidFill>
         </p:spPr>
         <p:txBody>
@@ -4179,8 +3746,8 @@
         </p:nvSpPr>
         <p:spPr>
           <a:xfrm>
-            <a:off x="800000" y="2700000"/>
-            <a:ext cx="10592000" cy="1400000"/>
+            <a:off x="500000" y="360000"/>
+            <a:ext cx="11192000" cy="760000"/>
           </a:xfrm>
           <a:prstGeom prst="rect">
             <a:avLst/>
@@ -4188,7 +3755,7 @@
           <a:noFill/>
         </p:spPr>
         <p:txBody>
-          <a:bodyPr wrap="square" lIns="91440" tIns="68580" rIns="91440" bIns="68580" anchor="ctr">
+          <a:bodyPr wrap="square" lIns="91440" tIns="68580" rIns="91440" bIns="68580" anchor="t">
             <a:normAutofit/>
           </a:bodyPr>
           <a:lstStyle/>
@@ -4197,12 +3764,144 @@
               <a:buNone/>
             </a:pPr>
             <a:r>
-              <a:rPr lang="fr-FR" sz="3600" b="1">
-                <a:solidFill>
-                  <a:srgbClr val="FFFFFF"/>
-                </a:solidFill>
-              </a:rPr>
-              <a:t>6. Repères — paiement &amp; statuts</a:t>
+              <a:rPr lang="fr-FR" sz="2600" b="1">
+                <a:solidFill>
+                  <a:srgbClr val="9B0F1E"/>
+                </a:solidFill>
+              </a:rPr>
+              <a:t>Distinguer réussi / échoué</a:t>
+            </a:r>
+          </a:p>
+        </p:txBody>
+      </p:sp>
+      <p:sp>
+        <p:nvSpPr>
+          <p:cNvPr id="4" name="body"/>
+          <p:cNvSpPr/>
+          <p:nvPr/>
+        </p:nvSpPr>
+        <p:spPr>
+          <a:xfrm>
+            <a:off x="500000" y="1300000"/>
+            <a:ext cx="5300000" cy="5158000"/>
+          </a:xfrm>
+          <a:prstGeom prst="rect">
+            <a:avLst/>
+          </a:prstGeom>
+          <a:noFill/>
+        </p:spPr>
+        <p:txBody>
+          <a:bodyPr wrap="square" lIns="91440" tIns="68580" rIns="91440" bIns="68580" anchor="t">
+            <a:normAutofit/>
+          </a:bodyPr>
+          <a:lstStyle/>
+          <a:p>
+            <a:pPr marL="228600" indent="-228600" algn="l">
+              <a:buChar char="•"/>
+            </a:pPr>
+            <a:r>
+              <a:rPr lang="fr-FR" sz="1500">
+                <a:solidFill>
+                  <a:srgbClr val="1E1416"/>
+                </a:solidFill>
+              </a:rPr>
+              <a:t>Client : écran VERT « Paiement réussi » vs écran ROUGE « Paiement non abouti / Solde insuffisant ».</a:t>
+            </a:r>
+          </a:p>
+          <a:p>
+            <a:pPr marL="228600" indent="-228600" algn="l">
+              <a:buChar char="•"/>
+            </a:pPr>
+            <a:r>
+              <a:rPr lang="fr-FR" sz="1500">
+                <a:solidFill>
+                  <a:srgbClr val="1E1416"/>
+                </a:solidFill>
+              </a:rPr>
+              <a:t>Utilisateurs : badge « Payée » (vert) vs « Échouée » (rouge) sur chaque dossier.</a:t>
+            </a:r>
+          </a:p>
+          <a:p>
+            <a:pPr marL="228600" indent="-228600" algn="l">
+              <a:buChar char="•"/>
+            </a:pPr>
+            <a:r>
+              <a:rPr lang="fr-FR" sz="1500">
+                <a:solidFill>
+                  <a:srgbClr val="1E1416"/>
+                </a:solidFill>
+              </a:rPr>
+              <a:t>Un échec n'est jamais masqué par une impression (statut « Échouée » prioritaire).</a:t>
+            </a:r>
+          </a:p>
+        </p:txBody>
+      </p:sp>
+      <p:sp>
+        <p:nvSpPr>
+          <p:cNvPr id="5" name="placeholder"/>
+          <p:cNvSpPr/>
+          <p:nvPr/>
+        </p:nvSpPr>
+        <p:spPr>
+          <a:xfrm>
+            <a:off x="6050000" y="1250000"/>
+            <a:ext cx="5650000" cy="5050000"/>
+          </a:xfrm>
+          <a:prstGeom prst="rect">
+            <a:avLst/>
+          </a:prstGeom>
+          <a:solidFill>
+            <a:srgbClr val="F4F4F4"/>
+          </a:solidFill>
+          <a:ln w="19050">
+            <a:solidFill>
+              <a:srgbClr val="BBBBBB"/>
+            </a:solidFill>
+            <a:prstDash val="dash"/>
+          </a:ln>
+        </p:spPr>
+        <p:txBody>
+          <a:bodyPr anchor="ctr">
+            <a:normAutofit/>
+          </a:bodyPr>
+          <a:lstStyle/>
+          <a:p>
+            <a:pPr marL="0" indent="0" algn="ctr">
+              <a:buNone/>
+            </a:pPr>
+            <a:r>
+              <a:rPr lang="fr-FR" sz="1600" b="1">
+                <a:solidFill>
+                  <a:srgbClr val="888888"/>
+                </a:solidFill>
+              </a:rPr>
+              <a:t>📷 Capture</a:t>
+            </a:r>
+          </a:p>
+          <a:p>
+            <a:pPr marL="0" indent="0" algn="ctr">
+              <a:buNone/>
+            </a:pPr>
+            <a:r>
+              <a:rPr lang="fr-FR" sz="1300">
+                <a:solidFill>
+                  <a:srgbClr val="888888"/>
+                </a:solidFill>
+              </a:rPr>
+              <a:t>Comparatif réussi vs échoué</a:t>
+            </a:r>
+          </a:p>
+          <a:p>
+            <a:pPr marL="0" indent="0" algn="ctr">
+              <a:buNone/>
+            </a:pPr>
+            <a:r>
+              <a:rPr lang="fr-FR" sz="1100">
+                <a:solidFill>
+                  <a:srgbClr val="AAAAAA"/>
+                </a:solidFill>
+              </a:rPr>
+              <a:t>(insérer la copie d’écran ici)</a:t>
             </a:r>
           </a:p>
         </p:txBody>
@@ -4265,7 +3964,7 @@
         </p:nvSpPr>
         <p:spPr>
           <a:xfrm>
-            <a:off x="500000" y="380000"/>
+            <a:off x="500000" y="360000"/>
             <a:ext cx="11192000" cy="760000"/>
           </a:xfrm>
           <a:prstGeom prst="rect">
@@ -4302,7 +4001,7 @@
         <p:spPr>
           <a:xfrm>
             <a:off x="500000" y="1300000"/>
-            <a:ext cx="5500000" cy="5158000"/>
+            <a:ext cx="5300000" cy="5158000"/>
           </a:xfrm>
           <a:prstGeom prst="rect">
             <a:avLst/>
@@ -4355,76 +4054,35 @@
           </a:p>
         </p:txBody>
       </p:sp>
-      <p:sp>
-        <p:nvSpPr>
-          <p:cNvPr id="5" name="placeholder"/>
-          <p:cNvSpPr/>
-          <p:nvPr/>
-        </p:nvSpPr>
-        <p:spPr>
-          <a:xfrm>
-            <a:off x="6250000" y="1300000"/>
-            <a:ext cx="5400000" cy="4700000"/>
-          </a:xfrm>
-          <a:prstGeom prst="rect">
-            <a:avLst/>
-          </a:prstGeom>
-          <a:solidFill>
-            <a:srgbClr val="F4F4F4"/>
-          </a:solidFill>
-          <a:ln w="19050">
+      <p:pic>
+        <p:nvPicPr>
+          <p:cNvPr id="5" name="img5"/>
+          <p:cNvPicPr>
+            <a:picLocks noChangeAspect="1"/>
+          </p:cNvPicPr>
+          <p:nvPr/>
+        </p:nvPicPr>
+        <p:blipFill>
+          <a:blip r:embed="rIdImg"/>
+          <a:stretch>
+            <a:fillRect/>
+          </a:stretch>
+        </p:blipFill>
+        <p:spPr>
+          <a:xfrm>
+            <a:off x="7639362" y="1250000"/>
+            <a:ext cx="2471276" cy="5050000"/>
+          </a:xfrm>
+          <a:prstGeom prst="rect">
+            <a:avLst/>
+          </a:prstGeom>
+          <a:ln w="9525">
             <a:solidFill>
-              <a:srgbClr val="BBBBBB"/>
+              <a:srgbClr val="DDDDDD"/>
             </a:solidFill>
-            <a:prstDash val="dash"/>
           </a:ln>
         </p:spPr>
-        <p:txBody>
-          <a:bodyPr anchor="ctr">
-            <a:normAutofit/>
-          </a:bodyPr>
-          <a:lstStyle/>
-          <a:p>
-            <a:pPr marL="0" indent="0" algn="ctr">
-              <a:buNone/>
-            </a:pPr>
-            <a:r>
-              <a:rPr lang="fr-FR" sz="1600" b="1">
-                <a:solidFill>
-                  <a:srgbClr val="888888"/>
-                </a:solidFill>
-              </a:rPr>
-              <a:t>📷 Capture</a:t>
-            </a:r>
-          </a:p>
-          <a:p>
-            <a:pPr marL="0" indent="0" algn="ctr">
-              <a:buNone/>
-            </a:pPr>
-            <a:r>
-              <a:rPr lang="fr-FR" sz="1300">
-                <a:solidFill>
-                  <a:srgbClr val="888888"/>
-                </a:solidFill>
-              </a:rPr>
-              <a:t>Écran de connexion</a:t>
-            </a:r>
-          </a:p>
-          <a:p>
-            <a:pPr marL="0" indent="0" algn="ctr">
-              <a:buNone/>
-            </a:pPr>
-            <a:r>
-              <a:rPr lang="fr-FR" sz="1100">
-                <a:solidFill>
-                  <a:srgbClr val="AAAAAA"/>
-                </a:solidFill>
-              </a:rPr>
-              <a:t>(insérer la copie d’écran ici)</a:t>
-            </a:r>
-          </a:p>
-        </p:txBody>
-      </p:sp>
+      </p:pic>
     </p:spTree>
   </p:cSld>
   <p:clrMapOvr>
@@ -4483,7 +4141,7 @@
         </p:nvSpPr>
         <p:spPr>
           <a:xfrm>
-            <a:off x="500000" y="380000"/>
+            <a:off x="500000" y="360000"/>
             <a:ext cx="11192000" cy="760000"/>
           </a:xfrm>
           <a:prstGeom prst="rect">
@@ -4506,7 +4164,7 @@
                   <a:srgbClr val="9B0F1E"/>
                 </a:solidFill>
               </a:rPr>
-              <a:t>Distinguer réussi / échoué</a:t>
+              <a:t>Légende des statuts</a:t>
             </a:r>
           </a:p>
         </p:txBody>
@@ -4520,7 +4178,7 @@
         <p:spPr>
           <a:xfrm>
             <a:off x="500000" y="1300000"/>
-            <a:ext cx="5500000" cy="5158000"/>
+            <a:ext cx="5300000" cy="5158000"/>
           </a:xfrm>
           <a:prstGeom prst="rect">
             <a:avLst/>
@@ -4542,33 +4200,33 @@
                   <a:srgbClr val="1E1416"/>
                 </a:solidFill>
               </a:rPr>
-              <a:t>Client : écran VERT « Paiement réussi » vs écran ROUGE « Paiement non abouti / Solde insuffisant ».</a:t>
-            </a:r>
-          </a:p>
-          <a:p>
-            <a:pPr marL="228600" indent="-228600" algn="l">
-              <a:buChar char="•"/>
-            </a:pPr>
-            <a:r>
-              <a:rPr lang="fr-FR" sz="1500">
-                <a:solidFill>
-                  <a:srgbClr val="1E1416"/>
-                </a:solidFill>
-              </a:rPr>
-              <a:t>Utilisateurs : badge « Payée » (vert) vs « Échouée » (rouge) sur chaque dossier.</a:t>
-            </a:r>
-          </a:p>
-          <a:p>
-            <a:pPr marL="228600" indent="-228600" algn="l">
-              <a:buChar char="•"/>
-            </a:pPr>
-            <a:r>
-              <a:rPr lang="fr-FR" sz="1500">
-                <a:solidFill>
-                  <a:srgbClr val="1E1416"/>
-                </a:solidFill>
-              </a:rPr>
-              <a:t>Un échec n'est jamais masqué par une impression (statut « Échouée » prioritaire).</a:t>
+              <a:t>Payée (vert) · Échouée (rouge) · KYC en attente (ambre).</a:t>
+            </a:r>
+          </a:p>
+          <a:p>
+            <a:pPr marL="228600" indent="-228600" algn="l">
+              <a:buChar char="•"/>
+            </a:pPr>
+            <a:r>
+              <a:rPr lang="fr-FR" sz="1500">
+                <a:solidFill>
+                  <a:srgbClr val="1E1416"/>
+                </a:solidFill>
+              </a:rPr>
+              <a:t>À payer espèces · SARA — à valider · Imprimée.</a:t>
+            </a:r>
+          </a:p>
+          <a:p>
+            <a:pPr marL="228600" indent="-228600" algn="l">
+              <a:buChar char="•"/>
+            </a:pPr>
+            <a:r>
+              <a:rPr lang="fr-FR" sz="1500">
+                <a:solidFill>
+                  <a:srgbClr val="1E1416"/>
+                </a:solidFill>
+              </a:rPr>
+              <a:t>Les badges apparaissent dans toutes les listes et le tableau admin.</a:t>
             </a:r>
           </a:p>
         </p:txBody>
@@ -4581,226 +4239,8 @@
         </p:nvSpPr>
         <p:spPr>
           <a:xfrm>
-            <a:off x="6250000" y="1300000"/>
-            <a:ext cx="5400000" cy="4700000"/>
-          </a:xfrm>
-          <a:prstGeom prst="rect">
-            <a:avLst/>
-          </a:prstGeom>
-          <a:solidFill>
-            <a:srgbClr val="F4F4F4"/>
-          </a:solidFill>
-          <a:ln w="19050">
-            <a:solidFill>
-              <a:srgbClr val="BBBBBB"/>
-            </a:solidFill>
-            <a:prstDash val="dash"/>
-          </a:ln>
-        </p:spPr>
-        <p:txBody>
-          <a:bodyPr anchor="ctr">
-            <a:normAutofit/>
-          </a:bodyPr>
-          <a:lstStyle/>
-          <a:p>
-            <a:pPr marL="0" indent="0" algn="ctr">
-              <a:buNone/>
-            </a:pPr>
-            <a:r>
-              <a:rPr lang="fr-FR" sz="1600" b="1">
-                <a:solidFill>
-                  <a:srgbClr val="888888"/>
-                </a:solidFill>
-              </a:rPr>
-              <a:t>📷 Capture</a:t>
-            </a:r>
-          </a:p>
-          <a:p>
-            <a:pPr marL="0" indent="0" algn="ctr">
-              <a:buNone/>
-            </a:pPr>
-            <a:r>
-              <a:rPr lang="fr-FR" sz="1300">
-                <a:solidFill>
-                  <a:srgbClr val="888888"/>
-                </a:solidFill>
-              </a:rPr>
-              <a:t>Comparatif réussi vs échoué</a:t>
-            </a:r>
-          </a:p>
-          <a:p>
-            <a:pPr marL="0" indent="0" algn="ctr">
-              <a:buNone/>
-            </a:pPr>
-            <a:r>
-              <a:rPr lang="fr-FR" sz="1100">
-                <a:solidFill>
-                  <a:srgbClr val="AAAAAA"/>
-                </a:solidFill>
-              </a:rPr>
-              <a:t>(insérer la copie d’écran ici)</a:t>
-            </a:r>
-          </a:p>
-        </p:txBody>
-      </p:sp>
-    </p:spTree>
-  </p:cSld>
-  <p:clrMapOvr>
-    <a:masterClrMapping/>
-  </p:clrMapOvr>
-</p:sld>
-</file>
-
-<file path=ppt/slides/slide31.xml><?xml version="1.0" encoding="utf-8"?>
-<p:sld xmlns:a="http://schemas.openxmlformats.org/drawingml/2006/main" xmlns:r="http://schemas.openxmlformats.org/officeDocument/2006/relationships" xmlns:p="http://schemas.openxmlformats.org/presentationml/2006/main">
-  <p:cSld>
-    <p:spTree>
-      <p:nvGrpSpPr>
-        <p:cNvPr id="1" name=""/>
-        <p:cNvGrpSpPr/>
-        <p:nvPr/>
-      </p:nvGrpSpPr>
-      <p:grpSpPr>
-        <a:xfrm>
-          <a:off x="0" y="0"/>
-          <a:ext cx="0" cy="0"/>
-          <a:chOff x="0" y="0"/>
-          <a:chExt cx="0" cy="0"/>
-        </a:xfrm>
-      </p:grpSpPr>
-      <p:sp>
-        <p:nvSpPr>
-          <p:cNvPr id="2" name="bg"/>
-          <p:cNvSpPr/>
-          <p:nvPr/>
-        </p:nvSpPr>
-        <p:spPr>
-          <a:xfrm>
-            <a:off x="0" y="0"/>
-            <a:ext cx="12192000" cy="6858000"/>
-          </a:xfrm>
-          <a:prstGeom prst="rect">
-            <a:avLst/>
-          </a:prstGeom>
-          <a:solidFill>
-            <a:srgbClr val="FFFFFF"/>
-          </a:solidFill>
-        </p:spPr>
-        <p:txBody>
-          <a:bodyPr wrap="square" lIns="91440" tIns="68580" rIns="91440" bIns="68580" anchor="t">
-            <a:normAutofit/>
-          </a:bodyPr>
-          <a:lstStyle/>
-        </p:txBody>
-      </p:sp>
-      <p:sp>
-        <p:nvSpPr>
-          <p:cNvPr id="3" name="title"/>
-          <p:cNvSpPr/>
-          <p:nvPr/>
-        </p:nvSpPr>
-        <p:spPr>
-          <a:xfrm>
-            <a:off x="500000" y="380000"/>
-            <a:ext cx="11192000" cy="760000"/>
-          </a:xfrm>
-          <a:prstGeom prst="rect">
-            <a:avLst/>
-          </a:prstGeom>
-          <a:noFill/>
-        </p:spPr>
-        <p:txBody>
-          <a:bodyPr wrap="square" lIns="91440" tIns="68580" rIns="91440" bIns="68580" anchor="t">
-            <a:normAutofit/>
-          </a:bodyPr>
-          <a:lstStyle/>
-          <a:p>
-            <a:pPr marL="0" indent="0" algn="l">
-              <a:buNone/>
-            </a:pPr>
-            <a:r>
-              <a:rPr lang="fr-FR" sz="2600" b="1">
-                <a:solidFill>
-                  <a:srgbClr val="9B0F1E"/>
-                </a:solidFill>
-              </a:rPr>
-              <a:t>Légende des statuts</a:t>
-            </a:r>
-          </a:p>
-        </p:txBody>
-      </p:sp>
-      <p:sp>
-        <p:nvSpPr>
-          <p:cNvPr id="4" name="body"/>
-          <p:cNvSpPr/>
-          <p:nvPr/>
-        </p:nvSpPr>
-        <p:spPr>
-          <a:xfrm>
-            <a:off x="500000" y="1300000"/>
-            <a:ext cx="5500000" cy="5158000"/>
-          </a:xfrm>
-          <a:prstGeom prst="rect">
-            <a:avLst/>
-          </a:prstGeom>
-          <a:noFill/>
-        </p:spPr>
-        <p:txBody>
-          <a:bodyPr wrap="square" lIns="91440" tIns="68580" rIns="91440" bIns="68580" anchor="t">
-            <a:normAutofit/>
-          </a:bodyPr>
-          <a:lstStyle/>
-          <a:p>
-            <a:pPr marL="228600" indent="-228600" algn="l">
-              <a:buChar char="•"/>
-            </a:pPr>
-            <a:r>
-              <a:rPr lang="fr-FR" sz="1500">
-                <a:solidFill>
-                  <a:srgbClr val="1E1416"/>
-                </a:solidFill>
-              </a:rPr>
-              <a:t>Payée (vert) · Échouée (rouge) · KYC en attente (ambre).</a:t>
-            </a:r>
-          </a:p>
-          <a:p>
-            <a:pPr marL="228600" indent="-228600" algn="l">
-              <a:buChar char="•"/>
-            </a:pPr>
-            <a:r>
-              <a:rPr lang="fr-FR" sz="1500">
-                <a:solidFill>
-                  <a:srgbClr val="1E1416"/>
-                </a:solidFill>
-              </a:rPr>
-              <a:t>À payer espèces · SARA — à valider · Imprimée.</a:t>
-            </a:r>
-          </a:p>
-          <a:p>
-            <a:pPr marL="228600" indent="-228600" algn="l">
-              <a:buChar char="•"/>
-            </a:pPr>
-            <a:r>
-              <a:rPr lang="fr-FR" sz="1500">
-                <a:solidFill>
-                  <a:srgbClr val="1E1416"/>
-                </a:solidFill>
-              </a:rPr>
-              <a:t>Les badges apparaissent dans toutes les listes et le tableau admin.</a:t>
-            </a:r>
-          </a:p>
-        </p:txBody>
-      </p:sp>
-      <p:sp>
-        <p:nvSpPr>
-          <p:cNvPr id="5" name="placeholder"/>
-          <p:cNvSpPr/>
-          <p:nvPr/>
-        </p:nvSpPr>
-        <p:spPr>
-          <a:xfrm>
-            <a:off x="6250000" y="1300000"/>
-            <a:ext cx="5400000" cy="4700000"/>
+            <a:off x="6050000" y="1250000"/>
+            <a:ext cx="5650000" cy="5050000"/>
           </a:xfrm>
           <a:prstGeom prst="rect">
             <a:avLst/>
@@ -4919,7 +4359,7 @@
         </p:nvSpPr>
         <p:spPr>
           <a:xfrm>
-            <a:off x="500000" y="380000"/>
+            <a:off x="500000" y="360000"/>
             <a:ext cx="11192000" cy="760000"/>
           </a:xfrm>
           <a:prstGeom prst="rect">
@@ -4956,7 +4396,7 @@
         <p:spPr>
           <a:xfrm>
             <a:off x="500000" y="1300000"/>
-            <a:ext cx="5500000" cy="5158000"/>
+            <a:ext cx="5300000" cy="5158000"/>
           </a:xfrm>
           <a:prstGeom prst="rect">
             <a:avLst/>
@@ -5017,8 +4457,8 @@
         </p:nvSpPr>
         <p:spPr>
           <a:xfrm>
-            <a:off x="6250000" y="1300000"/>
-            <a:ext cx="5400000" cy="4700000"/>
+            <a:off x="6050000" y="1250000"/>
+            <a:ext cx="5650000" cy="5050000"/>
           </a:xfrm>
           <a:prstGeom prst="rect">
             <a:avLst/>
@@ -5223,7 +4663,7 @@
         </p:nvSpPr>
         <p:spPr>
           <a:xfrm>
-            <a:off x="500000" y="380000"/>
+            <a:off x="500000" y="360000"/>
             <a:ext cx="11192000" cy="760000"/>
           </a:xfrm>
           <a:prstGeom prst="rect">
@@ -5260,7 +4700,7 @@
         <p:spPr>
           <a:xfrm>
             <a:off x="500000" y="1300000"/>
-            <a:ext cx="5500000" cy="5158000"/>
+            <a:ext cx="5300000" cy="5158000"/>
           </a:xfrm>
           <a:prstGeom prst="rect">
             <a:avLst/>
@@ -5313,76 +4753,35 @@
           </a:p>
         </p:txBody>
       </p:sp>
-      <p:sp>
-        <p:nvSpPr>
-          <p:cNvPr id="5" name="placeholder"/>
-          <p:cNvSpPr/>
-          <p:nvPr/>
-        </p:nvSpPr>
-        <p:spPr>
-          <a:xfrm>
-            <a:off x="6250000" y="1300000"/>
-            <a:ext cx="5400000" cy="4700000"/>
-          </a:xfrm>
-          <a:prstGeom prst="rect">
-            <a:avLst/>
-          </a:prstGeom>
-          <a:solidFill>
-            <a:srgbClr val="F4F4F4"/>
-          </a:solidFill>
-          <a:ln w="19050">
+      <p:pic>
+        <p:nvPicPr>
+          <p:cNvPr id="5" name="img5"/>
+          <p:cNvPicPr>
+            <a:picLocks noChangeAspect="1"/>
+          </p:cNvPicPr>
+          <p:nvPr/>
+        </p:nvPicPr>
+        <p:blipFill>
+          <a:blip r:embed="rIdImg"/>
+          <a:stretch>
+            <a:fillRect/>
+          </a:stretch>
+        </p:blipFill>
+        <p:spPr>
+          <a:xfrm>
+            <a:off x="7639362" y="1250000"/>
+            <a:ext cx="2471276" cy="5050000"/>
+          </a:xfrm>
+          <a:prstGeom prst="rect">
+            <a:avLst/>
+          </a:prstGeom>
+          <a:ln w="9525">
             <a:solidFill>
-              <a:srgbClr val="BBBBBB"/>
+              <a:srgbClr val="DDDDDD"/>
             </a:solidFill>
-            <a:prstDash val="dash"/>
           </a:ln>
         </p:spPr>
-        <p:txBody>
-          <a:bodyPr anchor="ctr">
-            <a:normAutofit/>
-          </a:bodyPr>
-          <a:lstStyle/>
-          <a:p>
-            <a:pPr marL="0" indent="0" algn="ctr">
-              <a:buNone/>
-            </a:pPr>
-            <a:r>
-              <a:rPr lang="fr-FR" sz="1600" b="1">
-                <a:solidFill>
-                  <a:srgbClr val="888888"/>
-                </a:solidFill>
-              </a:rPr>
-              <a:t>📷 Capture</a:t>
-            </a:r>
-          </a:p>
-          <a:p>
-            <a:pPr marL="0" indent="0" algn="ctr">
-              <a:buNone/>
-            </a:pPr>
-            <a:r>
-              <a:rPr lang="fr-FR" sz="1300">
-                <a:solidFill>
-                  <a:srgbClr val="888888"/>
-                </a:solidFill>
-              </a:rPr>
-              <a:t>Accueil client (après scan du QR)</a:t>
-            </a:r>
-          </a:p>
-          <a:p>
-            <a:pPr marL="0" indent="0" algn="ctr">
-              <a:buNone/>
-            </a:pPr>
-            <a:r>
-              <a:rPr lang="fr-FR" sz="1100">
-                <a:solidFill>
-                  <a:srgbClr val="AAAAAA"/>
-                </a:solidFill>
-              </a:rPr>
-              <a:t>(insérer la copie d’écran ici)</a:t>
-            </a:r>
-          </a:p>
-        </p:txBody>
-      </p:sp>
+      </p:pic>
     </p:spTree>
   </p:cSld>
   <p:clrMapOvr>
@@ -5441,7 +4840,7 @@
         </p:nvSpPr>
         <p:spPr>
           <a:xfrm>
-            <a:off x="500000" y="380000"/>
+            <a:off x="500000" y="360000"/>
             <a:ext cx="11192000" cy="760000"/>
           </a:xfrm>
           <a:prstGeom prst="rect">
@@ -5478,7 +4877,7 @@
         <p:spPr>
           <a:xfrm>
             <a:off x="500000" y="1300000"/>
-            <a:ext cx="5500000" cy="5158000"/>
+            <a:ext cx="5300000" cy="5158000"/>
           </a:xfrm>
           <a:prstGeom prst="rect">
             <a:avLst/>
@@ -5544,76 +4943,35 @@
           </a:p>
         </p:txBody>
       </p:sp>
-      <p:sp>
-        <p:nvSpPr>
-          <p:cNvPr id="5" name="placeholder"/>
-          <p:cNvSpPr/>
-          <p:nvPr/>
-        </p:nvSpPr>
-        <p:spPr>
-          <a:xfrm>
-            <a:off x="6250000" y="1300000"/>
-            <a:ext cx="5400000" cy="4700000"/>
-          </a:xfrm>
-          <a:prstGeom prst="rect">
-            <a:avLst/>
-          </a:prstGeom>
-          <a:solidFill>
-            <a:srgbClr val="F4F4F4"/>
-          </a:solidFill>
-          <a:ln w="19050">
+      <p:pic>
+        <p:nvPicPr>
+          <p:cNvPr id="5" name="img5"/>
+          <p:cNvPicPr>
+            <a:picLocks noChangeAspect="1"/>
+          </p:cNvPicPr>
+          <p:nvPr/>
+        </p:nvPicPr>
+        <p:blipFill>
+          <a:blip r:embed="rIdImg"/>
+          <a:stretch>
+            <a:fillRect/>
+          </a:stretch>
+        </p:blipFill>
+        <p:spPr>
+          <a:xfrm>
+            <a:off x="7639362" y="1250000"/>
+            <a:ext cx="2471276" cy="5050000"/>
+          </a:xfrm>
+          <a:prstGeom prst="rect">
+            <a:avLst/>
+          </a:prstGeom>
+          <a:ln w="9525">
             <a:solidFill>
-              <a:srgbClr val="BBBBBB"/>
+              <a:srgbClr val="DDDDDD"/>
             </a:solidFill>
-            <a:prstDash val="dash"/>
           </a:ln>
         </p:spPr>
-        <p:txBody>
-          <a:bodyPr anchor="ctr">
-            <a:normAutofit/>
-          </a:bodyPr>
-          <a:lstStyle/>
-          <a:p>
-            <a:pPr marL="0" indent="0" algn="ctr">
-              <a:buNone/>
-            </a:pPr>
-            <a:r>
-              <a:rPr lang="fr-FR" sz="1600" b="1">
-                <a:solidFill>
-                  <a:srgbClr val="888888"/>
-                </a:solidFill>
-              </a:rPr>
-              <a:t>📷 Capture</a:t>
-            </a:r>
-          </a:p>
-          <a:p>
-            <a:pPr marL="0" indent="0" algn="ctr">
-              <a:buNone/>
-            </a:pPr>
-            <a:r>
-              <a:rPr lang="fr-FR" sz="1300">
-                <a:solidFill>
-                  <a:srgbClr val="888888"/>
-                </a:solidFill>
-              </a:rPr>
-              <a:t>Formulaire d'identité</a:t>
-            </a:r>
-          </a:p>
-          <a:p>
-            <a:pPr marL="0" indent="0" algn="ctr">
-              <a:buNone/>
-            </a:pPr>
-            <a:r>
-              <a:rPr lang="fr-FR" sz="1100">
-                <a:solidFill>
-                  <a:srgbClr val="AAAAAA"/>
-                </a:solidFill>
-              </a:rPr>
-              <a:t>(insérer la copie d’écran ici)</a:t>
-            </a:r>
-          </a:p>
-        </p:txBody>
-      </p:sp>
+      </p:pic>
     </p:spTree>
   </p:cSld>
   <p:clrMapOvr>
@@ -5672,7 +5030,7 @@
         </p:nvSpPr>
         <p:spPr>
           <a:xfrm>
-            <a:off x="500000" y="380000"/>
+            <a:off x="500000" y="360000"/>
             <a:ext cx="11192000" cy="760000"/>
           </a:xfrm>
           <a:prstGeom prst="rect">
@@ -5709,7 +5067,7 @@
         <p:spPr>
           <a:xfrm>
             <a:off x="500000" y="1300000"/>
-            <a:ext cx="5500000" cy="5158000"/>
+            <a:ext cx="5300000" cy="5158000"/>
           </a:xfrm>
           <a:prstGeom prst="rect">
             <a:avLst/>
@@ -5770,8 +5128,8 @@
         </p:nvSpPr>
         <p:spPr>
           <a:xfrm>
-            <a:off x="6250000" y="1300000"/>
-            <a:ext cx="5400000" cy="4700000"/>
+            <a:off x="6050000" y="1250000"/>
+            <a:ext cx="5650000" cy="5050000"/>
           </a:xfrm>
           <a:prstGeom prst="rect">
             <a:avLst/>
@@ -5890,7 +5248,7 @@
         </p:nvSpPr>
         <p:spPr>
           <a:xfrm>
-            <a:off x="500000" y="380000"/>
+            <a:off x="500000" y="360000"/>
             <a:ext cx="11192000" cy="760000"/>
           </a:xfrm>
           <a:prstGeom prst="rect">
@@ -5927,7 +5285,7 @@
         <p:spPr>
           <a:xfrm>
             <a:off x="500000" y="1300000"/>
-            <a:ext cx="5500000" cy="5158000"/>
+            <a:ext cx="5300000" cy="5158000"/>
           </a:xfrm>
           <a:prstGeom prst="rect">
             <a:avLst/>
@@ -5988,8 +5346,8 @@
         </p:nvSpPr>
         <p:spPr>
           <a:xfrm>
-            <a:off x="6250000" y="1300000"/>
-            <a:ext cx="5400000" cy="4700000"/>
+            <a:off x="6050000" y="1250000"/>
+            <a:ext cx="5650000" cy="5050000"/>
           </a:xfrm>
           <a:prstGeom prst="rect">
             <a:avLst/>

</xml_diff>